<commit_message>
Richt de MostWare Next-deck op Maurice en de lopende samenwerking
De cover benoemt dat we al voor HeadsUp bellen en positioneert dit
als de nieuwe pilot met een vast aantal afspraken en wekelijkse
cijfers. De pilotslide heet nu de nieuwe pilot, zodat het verschil
met de bestaande opzet meteen duidelijk is.

Co-Authored-By: Claude Opus 5 <noreply@anthropic.com>
Claude-Session: https://claude.ai/code/session_0141FN3f3hHkYQHTyvTJJGrw
</commit_message>
<xml_diff>
--- a/output/LINK. kennismaking MostWare Next.pptx
+++ b/output/LINK. kennismaking MostWare Next.pptx
@@ -2401,7 +2401,7 @@
                 <a:ea typeface="Arial" pitchFamily="34" charset="-122"/>
                 <a:cs typeface="Arial" pitchFamily="34" charset="-120"/>
               </a:rPr>
-              <a:t>VOOR MOSTWARE NEXT · SEPTEMBER 2026</a:t>
+              <a:t>VOOR MAURICE · MOSTWARE NEXT · SEPTEMBER 2026</a:t>
             </a:r>
             <a:endParaRPr lang="en-US" sz="950" dirty="0"/>
           </a:p>
@@ -2519,7 +2519,7 @@
                 <a:ea typeface="Arial" pitchFamily="34" charset="-122"/>
                 <a:cs typeface="Arial" pitchFamily="34" charset="-120"/>
               </a:rPr>
-              <a:t>Wat LINK. voor MostWare Next kan betekenen: structureel gesprekken met bedrijven die nog niet weten wat jullie te bieden hebben, en na twaalf weken een plan op basis van echte cijfers.</a:t>
+              <a:t>We bellen al voor HeadsUp. Voor MostWare Next stellen we onze nieuwe pilot voor: een vast aantal gekwalificeerde afspraken, elke week cijfers en na twaalf weken een onderbouwd plan.</a:t>
             </a:r>
             <a:endParaRPr lang="en-US" sz="1400" dirty="0"/>
           </a:p>
@@ -3077,7 +3077,7 @@
                 <a:ea typeface="Arial" pitchFamily="34" charset="-122"/>
                 <a:cs typeface="Arial" pitchFamily="34" charset="-120"/>
               </a:rPr>
-              <a:t>Jullie geven akkoord op het pilotvoorstel.</a:t>
+              <a:t>Maurice geeft akkoord op het pilotvoorstel.</a:t>
             </a:r>
             <a:endParaRPr lang="en-US" sz="1100" dirty="0"/>
           </a:p>
@@ -3926,7 +3926,7 @@
                 <a:ea typeface="Arial" pitchFamily="34" charset="-122"/>
                 <a:cs typeface="Arial" pitchFamily="34" charset="-120"/>
               </a:rPr>
-              <a:t>We werken voor bedrijven met een sterke B2B-propositie, in uiteenlopende branches. Geen bureau op afstand, maar een partner die elke week met je schakelt.</a:t>
+              <a:t>Voor HeadsUp bellen we al. Geen bureau op afstand, maar een partner die elke week met je schakelt.</a:t>
             </a:r>
             <a:endParaRPr lang="en-US" sz="1350" dirty="0"/>
           </a:p>
@@ -7321,7 +7321,7 @@
                 <a:ea typeface="Arial" pitchFamily="34" charset="-122"/>
                 <a:cs typeface="Arial" pitchFamily="34" charset="-120"/>
               </a:rPr>
-              <a:t>DE STANDAARDPILOT</a:t>
+              <a:t>DE NIEUWE PILOT</a:t>
             </a:r>
             <a:endParaRPr lang="en-US" sz="950" dirty="0"/>
           </a:p>
@@ -10079,7 +10079,7 @@
                 <a:ea typeface="Arial" pitchFamily="34" charset="-122"/>
                 <a:cs typeface="Arial" pitchFamily="34" charset="-120"/>
               </a:rPr>
-              <a:t>Anderhalf tot twee uur met de beslisser en degene die de afspraken gaat voeren.</a:t>
+              <a:t>Anderhalf tot twee uur met Maurice en degene die de afspraken gaat voeren.</a:t>
             </a:r>
             <a:endParaRPr lang="en-US" sz="1050" dirty="0"/>
           </a:p>

</xml_diff>